<commit_message>
docs: criados 3 slides dedicados para cada evidencia de email (1 por lamina)
</commit_message>
<xml_diff>
--- a/docs/Apresentacao_Hyperautomation_Processo1_LG.pptx
+++ b/docs/Apresentacao_Hyperautomation_Processo1_LG.pptx
@@ -26,6 +26,8 @@
     <p:sldId id="274" r:id="rId25"/>
     <p:sldId id="275" r:id="rId26"/>
     <p:sldId id="276" r:id="rId27"/>
+    <p:sldId id="277" r:id="rId28"/>
+    <p:sldId id="278" r:id="rId29"/>
   </p:sldIdLst>
   <p:sldSz cx="12191695" cy="6858000" type="screen4x3"/>
   <p:notesSz cx="6858000" cy="9144000"/>
@@ -7840,7 +7842,7 @@
               </a:defRPr>
             </a:pPr>
             <a:r>
-              <a:t>Evidências Práticas: Confirmações &amp; Pendências Identificadas</a:t>
+              <a:t>Evidência 1: Confirmação de Cadastro Aprovado (E-mail HTML)</a:t>
             </a:r>
           </a:p>
         </p:txBody>
@@ -7913,8 +7915,8 @@
         </p:blipFill>
         <p:spPr>
           <a:xfrm>
-            <a:off x="457200" y="1280160"/>
-            <a:ext cx="3474720" cy="1490516"/>
+            <a:off x="548640" y="1280160"/>
+            <a:ext cx="7132320" cy="3059479"/>
           </a:xfrm>
           <a:prstGeom prst="rect">
             <a:avLst/>
@@ -7929,8 +7931,8 @@
         </p:nvSpPr>
         <p:spPr>
           <a:xfrm>
-            <a:off x="457200" y="4754880"/>
-            <a:ext cx="3474720" cy="1371600"/>
+            <a:off x="7863840" y="1280160"/>
+            <a:ext cx="3749039" cy="4754880"/>
           </a:xfrm>
           <a:prstGeom prst="roundRect">
             <a:avLst/>
@@ -7973,7 +7975,7 @@
               </a:defRPr>
             </a:pPr>
             <a:r>
-              <a:t>✅ E-mail de Sucesso</a:t>
+              <a:t>✅ Cenário de Sucesso</a:t>
             </a:r>
           </a:p>
           <a:p>
@@ -7988,7 +7990,7 @@
                   <a:srgbClr val="333333"/>
                 </a:solidFill>
               </a:rPr>
-              <a:t>• Retorno do Robô: </a:t>
+              <a:t>• Validação Documental: </a:t>
             </a:r>
             <a:r>
               <a:rPr sz="1100">
@@ -7996,88 +7998,7 @@
                   <a:srgbClr val="333333"/>
                 </a:solidFill>
               </a:rPr>
-              <a:t>Confirmação de aprovação e cadastro ativado no ERP.</a:t>
-            </a:r>
-          </a:p>
-        </p:txBody>
-      </p:sp>
-      <p:pic>
-        <p:nvPicPr>
-          <p:cNvPr id="9" name="Picture 8" descr="falha_faltou_documento_foto.png"/>
-          <p:cNvPicPr>
-            <a:picLocks noChangeAspect="1"/>
-          </p:cNvPicPr>
-          <p:nvPr/>
-        </p:nvPicPr>
-        <p:blipFill>
-          <a:blip r:embed="rId3"/>
-          <a:stretch>
-            <a:fillRect/>
-          </a:stretch>
-        </p:blipFill>
-        <p:spPr>
-          <a:xfrm>
-            <a:off x="4297680" y="1280160"/>
-            <a:ext cx="3474720" cy="1490516"/>
-          </a:xfrm>
-          <a:prstGeom prst="rect">
-            <a:avLst/>
-          </a:prstGeom>
-        </p:spPr>
-      </p:pic>
-      <p:sp>
-        <p:nvSpPr>
-          <p:cNvPr id="10" name="Rounded Rectangle 9"/>
-          <p:cNvSpPr/>
-          <p:nvPr/>
-        </p:nvSpPr>
-        <p:spPr>
-          <a:xfrm>
-            <a:off x="4297680" y="4754880"/>
-            <a:ext cx="3474720" cy="1371600"/>
-          </a:xfrm>
-          <a:prstGeom prst="roundRect">
-            <a:avLst/>
-          </a:prstGeom>
-          <a:solidFill>
-            <a:srgbClr val="EEF1F5"/>
-          </a:solidFill>
-          <a:ln w="12700">
-            <a:solidFill>
-              <a:srgbClr val="D0D7DE"/>
-            </a:solidFill>
-          </a:ln>
-        </p:spPr>
-        <p:style>
-          <a:lnRef idx="1">
-            <a:schemeClr val="accent1"/>
-          </a:lnRef>
-          <a:fillRef idx="3">
-            <a:schemeClr val="accent1"/>
-          </a:fillRef>
-          <a:effectRef idx="2">
-            <a:schemeClr val="accent1"/>
-          </a:effectRef>
-          <a:fontRef idx="minor">
-            <a:schemeClr val="lt1"/>
-          </a:fontRef>
-        </p:style>
-        <p:txBody>
-          <a:bodyPr rtlCol="0" anchor="ctr" wrap="square" lIns="182880" rIns="182880" tIns="182880" bIns="182880"/>
-          <a:lstStyle/>
-          <a:p>
-            <a:pPr algn="ctr">
-              <a:spcAft>
-                <a:spcPts val="800"/>
-              </a:spcAft>
-              <a:defRPr sz="1400" b="1">
-                <a:solidFill>
-                  <a:srgbClr val="A50034"/>
-                </a:solidFill>
-              </a:defRPr>
-            </a:pPr>
-            <a:r>
-              <a:t>⚠️ Pendência: Doc. Foto</a:t>
+              <a:t>100% Aprovado.</a:t>
             </a:r>
           </a:p>
           <a:p>
@@ -8092,7 +8013,7 @@
                   <a:srgbClr val="333333"/>
                 </a:solidFill>
               </a:rPr>
-              <a:t>• Retorno do Robô: </a:t>
+              <a:t>• Análise do PDF: </a:t>
             </a:r>
             <a:r>
               <a:rPr sz="1100">
@@ -8100,88 +8021,7 @@
                   <a:srgbClr val="333333"/>
                 </a:solidFill>
               </a:rPr>
-              <a:t>Identificada ausência de Documento Oficial com Foto.</a:t>
-            </a:r>
-          </a:p>
-        </p:txBody>
-      </p:sp>
-      <p:pic>
-        <p:nvPicPr>
-          <p:cNvPr id="11" name="Picture 10" descr="falha_falta-comprovante-residencia.png"/>
-          <p:cNvPicPr>
-            <a:picLocks noChangeAspect="1"/>
-          </p:cNvPicPr>
-          <p:nvPr/>
-        </p:nvPicPr>
-        <p:blipFill>
-          <a:blip r:embed="rId4"/>
-          <a:stretch>
-            <a:fillRect/>
-          </a:stretch>
-        </p:blipFill>
-        <p:spPr>
-          <a:xfrm>
-            <a:off x="8138160" y="1280160"/>
-            <a:ext cx="3474720" cy="1490516"/>
-          </a:xfrm>
-          <a:prstGeom prst="rect">
-            <a:avLst/>
-          </a:prstGeom>
-        </p:spPr>
-      </p:pic>
-      <p:sp>
-        <p:nvSpPr>
-          <p:cNvPr id="12" name="Rounded Rectangle 11"/>
-          <p:cNvSpPr/>
-          <p:nvPr/>
-        </p:nvSpPr>
-        <p:spPr>
-          <a:xfrm>
-            <a:off x="8138160" y="4754880"/>
-            <a:ext cx="3474720" cy="1371600"/>
-          </a:xfrm>
-          <a:prstGeom prst="roundRect">
-            <a:avLst/>
-          </a:prstGeom>
-          <a:solidFill>
-            <a:srgbClr val="EEF1F5"/>
-          </a:solidFill>
-          <a:ln w="12700">
-            <a:solidFill>
-              <a:srgbClr val="D0D7DE"/>
-            </a:solidFill>
-          </a:ln>
-        </p:spPr>
-        <p:style>
-          <a:lnRef idx="1">
-            <a:schemeClr val="accent1"/>
-          </a:lnRef>
-          <a:fillRef idx="3">
-            <a:schemeClr val="accent1"/>
-          </a:fillRef>
-          <a:effectRef idx="2">
-            <a:schemeClr val="accent1"/>
-          </a:effectRef>
-          <a:fontRef idx="minor">
-            <a:schemeClr val="lt1"/>
-          </a:fontRef>
-        </p:style>
-        <p:txBody>
-          <a:bodyPr rtlCol="0" anchor="ctr" wrap="square" lIns="182880" rIns="182880" tIns="182880" bIns="182880"/>
-          <a:lstStyle/>
-          <a:p>
-            <a:pPr algn="ctr">
-              <a:spcAft>
-                <a:spcPts val="800"/>
-              </a:spcAft>
-              <a:defRPr sz="1400" b="1">
-                <a:solidFill>
-                  <a:srgbClr val="A50034"/>
-                </a:solidFill>
-              </a:defRPr>
-            </a:pPr>
-            <a:r>
-              <a:t>⚠️ Pendência: Residência</a:t>
+              <a:t>Ficha Cadastral Assinada, Documento com Foto e Comprovante de Residência validados via pypdf.</a:t>
             </a:r>
           </a:p>
           <a:p>
@@ -8196,7 +8036,7 @@
                   <a:srgbClr val="333333"/>
                 </a:solidFill>
               </a:rPr>
-              <a:t>• Retorno do Robô: </a:t>
+              <a:t>• Automação Web: </a:t>
             </a:r>
             <a:r>
               <a:rPr sz="1100">
@@ -8204,14 +8044,60 @@
                   <a:srgbClr val="333333"/>
                 </a:solidFill>
               </a:rPr>
-              <a:t>Identificada ausência de Comprovante de Residência.</a:t>
-            </a:r>
-          </a:p>
-        </p:txBody>
-      </p:sp>
-      <p:sp>
-        <p:nvSpPr>
-          <p:cNvPr id="13" name="TextBox 12"/>
+              <a:t>Cadastro ativado no Portal Fake ERP como 'ATIVO' via Playwright.</a:t>
+            </a:r>
+          </a:p>
+          <a:p>
+            <a:pPr>
+              <a:spcAft>
+                <a:spcPts val="600"/>
+              </a:spcAft>
+            </a:pPr>
+            <a:r>
+              <a:rPr b="1" sz="1100">
+                <a:solidFill>
+                  <a:srgbClr val="333333"/>
+                </a:solidFill>
+              </a:rPr>
+              <a:t>• Gestão de Arquivos: </a:t>
+            </a:r>
+            <a:r>
+              <a:rPr sz="1100">
+                <a:solidFill>
+                  <a:srgbClr val="333333"/>
+                </a:solidFill>
+              </a:rPr>
+              <a:t>Arquivo transferido para 'Documentos_OK' e depois 'Encaminhados' (local e Google Drive).</a:t>
+            </a:r>
+          </a:p>
+          <a:p>
+            <a:pPr>
+              <a:spcAft>
+                <a:spcPts val="600"/>
+              </a:spcAft>
+            </a:pPr>
+            <a:r>
+              <a:rPr b="1" sz="1100">
+                <a:solidFill>
+                  <a:srgbClr val="333333"/>
+                </a:solidFill>
+              </a:rPr>
+              <a:t>• Notificação: </a:t>
+            </a:r>
+            <a:r>
+              <a:rPr sz="1100">
+                <a:solidFill>
+                  <a:srgbClr val="333333"/>
+                </a:solidFill>
+              </a:rPr>
+              <a:t>Disparo instantâneo do e-mail em HTML responsivo com protocolo único de aprovação.</a:t>
+            </a:r>
+          </a:p>
+        </p:txBody>
+      </p:sp>
+      <p:sp>
+        <p:nvSpPr>
+          <p:cNvPr id="9" name="TextBox 8"/>
           <p:cNvSpPr txBox="1"/>
           <p:nvPr/>
         </p:nvSpPr>
@@ -8239,7 +8125,7 @@
               </a:defRPr>
             </a:pPr>
             <a:r>
-              <a:t>Empresa Portal Fake — Processo 1 (Setor de Atendimento) | Técnicas de Hyperautomation (LG / IFAM / FAEPI) | Slide 19 de 21</a:t>
+              <a:t>Empresa Portal Fake — Processo 1 (Setor de Atendimento) | Técnicas de Hyperautomation (LG / IFAM / FAEPI) | Slide 19 de 23</a:t>
             </a:r>
           </a:p>
         </p:txBody>
@@ -9120,6 +9006,894 @@
 </file>
 
 <file path=ppt/slides/slide20.xml><?xml version="1.0" encoding="utf-8"?>
+<p:sld xmlns:a="http://schemas.openxmlformats.org/drawingml/2006/main" xmlns:p="http://schemas.openxmlformats.org/presentationml/2006/main" xmlns:r="http://schemas.openxmlformats.org/officeDocument/2006/relationships">
+  <p:cSld>
+    <p:bg>
+      <p:bgPr>
+        <a:solidFill>
+          <a:srgbClr val="F8F9FA"/>
+        </a:solidFill>
+        <a:effectLst/>
+      </p:bgPr>
+    </p:bg>
+    <p:spTree>
+      <p:nvGrpSpPr>
+        <p:cNvPr id="1" name=""/>
+        <p:cNvGrpSpPr/>
+        <p:nvPr/>
+      </p:nvGrpSpPr>
+      <p:grpSpPr/>
+      <p:sp>
+        <p:nvSpPr>
+          <p:cNvPr id="2" name="Rectangle 1"/>
+          <p:cNvSpPr/>
+          <p:nvPr/>
+        </p:nvSpPr>
+        <p:spPr>
+          <a:xfrm>
+            <a:off x="0" y="0"/>
+            <a:ext cx="12191695" cy="1005840"/>
+          </a:xfrm>
+          <a:prstGeom prst="rect">
+            <a:avLst/>
+          </a:prstGeom>
+          <a:solidFill>
+            <a:srgbClr val="FFFFFF"/>
+          </a:solidFill>
+          <a:ln w="12700">
+            <a:solidFill>
+              <a:srgbClr val="D0D7DE"/>
+            </a:solidFill>
+          </a:ln>
+        </p:spPr>
+        <p:style>
+          <a:lnRef idx="1">
+            <a:schemeClr val="accent1"/>
+          </a:lnRef>
+          <a:fillRef idx="3">
+            <a:schemeClr val="accent1"/>
+          </a:fillRef>
+          <a:effectRef idx="2">
+            <a:schemeClr val="accent1"/>
+          </a:effectRef>
+          <a:fontRef idx="minor">
+            <a:schemeClr val="lt1"/>
+          </a:fontRef>
+        </p:style>
+        <p:txBody>
+          <a:bodyPr rtlCol="0" anchor="ctr"/>
+          <a:lstStyle/>
+          <a:p>
+            <a:pPr algn="ctr"/>
+          </a:p>
+        </p:txBody>
+      </p:sp>
+      <p:sp>
+        <p:nvSpPr>
+          <p:cNvPr id="3" name="Rectangle 2"/>
+          <p:cNvSpPr/>
+          <p:nvPr/>
+        </p:nvSpPr>
+        <p:spPr>
+          <a:xfrm>
+            <a:off x="457200" y="182880"/>
+            <a:ext cx="109728" cy="640080"/>
+          </a:xfrm>
+          <a:prstGeom prst="rect">
+            <a:avLst/>
+          </a:prstGeom>
+          <a:solidFill>
+            <a:srgbClr val="A50034"/>
+          </a:solidFill>
+          <a:ln>
+            <a:noFill/>
+          </a:ln>
+        </p:spPr>
+        <p:style>
+          <a:lnRef idx="1">
+            <a:schemeClr val="accent1"/>
+          </a:lnRef>
+          <a:fillRef idx="3">
+            <a:schemeClr val="accent1"/>
+          </a:fillRef>
+          <a:effectRef idx="2">
+            <a:schemeClr val="accent1"/>
+          </a:effectRef>
+          <a:fontRef idx="minor">
+            <a:schemeClr val="lt1"/>
+          </a:fontRef>
+        </p:style>
+        <p:txBody>
+          <a:bodyPr rtlCol="0" anchor="ctr"/>
+          <a:lstStyle/>
+          <a:p>
+            <a:pPr algn="ctr"/>
+          </a:p>
+        </p:txBody>
+      </p:sp>
+      <p:sp>
+        <p:nvSpPr>
+          <p:cNvPr id="4" name="TextBox 3"/>
+          <p:cNvSpPr txBox="1"/>
+          <p:nvPr/>
+        </p:nvSpPr>
+        <p:spPr>
+          <a:xfrm>
+            <a:off x="685800" y="137160"/>
+            <a:ext cx="8229600" cy="274320"/>
+          </a:xfrm>
+          <a:prstGeom prst="rect">
+            <a:avLst/>
+          </a:prstGeom>
+          <a:noFill/>
+        </p:spPr>
+        <p:txBody>
+          <a:bodyPr wrap="square">
+            <a:spAutoFit/>
+          </a:bodyPr>
+          <a:lstStyle/>
+          <a:p>
+            <a:pPr>
+              <a:defRPr sz="1000" b="1">
+                <a:solidFill>
+                  <a:srgbClr val="A50034"/>
+                </a:solidFill>
+              </a:defRPr>
+            </a:pPr>
+            <a:r>
+              <a:t>BLOCO 4 — DEMONSTRAÇÃO &amp; RESULTADOS</a:t>
+            </a:r>
+          </a:p>
+        </p:txBody>
+      </p:sp>
+      <p:sp>
+        <p:nvSpPr>
+          <p:cNvPr id="5" name="TextBox 4"/>
+          <p:cNvSpPr txBox="1"/>
+          <p:nvPr/>
+        </p:nvSpPr>
+        <p:spPr>
+          <a:xfrm>
+            <a:off x="685800" y="365760"/>
+            <a:ext cx="8229600" cy="548640"/>
+          </a:xfrm>
+          <a:prstGeom prst="rect">
+            <a:avLst/>
+          </a:prstGeom>
+          <a:noFill/>
+        </p:spPr>
+        <p:txBody>
+          <a:bodyPr wrap="square">
+            <a:spAutoFit/>
+          </a:bodyPr>
+          <a:lstStyle/>
+          <a:p>
+            <a:pPr>
+              <a:defRPr sz="2000" b="1">
+                <a:solidFill>
+                  <a:srgbClr val="333333"/>
+                </a:solidFill>
+              </a:defRPr>
+            </a:pPr>
+            <a:r>
+              <a:t>Evidência 2: Pendência — Falta Documento Oficial com Foto</a:t>
+            </a:r>
+          </a:p>
+        </p:txBody>
+      </p:sp>
+      <p:sp>
+        <p:nvSpPr>
+          <p:cNvPr id="6" name="Rounded Rectangle 5"/>
+          <p:cNvSpPr/>
+          <p:nvPr/>
+        </p:nvSpPr>
+        <p:spPr>
+          <a:xfrm>
+            <a:off x="8961120" y="274320"/>
+            <a:ext cx="2743200" cy="457200"/>
+          </a:xfrm>
+          <a:prstGeom prst="roundRect">
+            <a:avLst/>
+          </a:prstGeom>
+          <a:solidFill>
+            <a:srgbClr val="A50034"/>
+          </a:solidFill>
+          <a:ln>
+            <a:noFill/>
+          </a:ln>
+        </p:spPr>
+        <p:style>
+          <a:lnRef idx="1">
+            <a:schemeClr val="accent1"/>
+          </a:lnRef>
+          <a:fillRef idx="3">
+            <a:schemeClr val="accent1"/>
+          </a:fillRef>
+          <a:effectRef idx="2">
+            <a:schemeClr val="accent1"/>
+          </a:effectRef>
+          <a:fontRef idx="minor">
+            <a:schemeClr val="lt1"/>
+          </a:fontRef>
+        </p:style>
+        <p:txBody>
+          <a:bodyPr rtlCol="0" anchor="ctr"/>
+          <a:lstStyle/>
+          <a:p>
+            <a:pPr algn="ctr">
+              <a:defRPr sz="1100" b="1">
+                <a:solidFill>
+                  <a:srgbClr val="FFFFFF"/>
+                </a:solidFill>
+              </a:defRPr>
+            </a:pPr>
+            <a:r>
+              <a:t>Equipe Integrada</a:t>
+            </a:r>
+          </a:p>
+        </p:txBody>
+      </p:sp>
+      <p:pic>
+        <p:nvPicPr>
+          <p:cNvPr id="7" name="Picture 6" descr="falha_faltou_documento_foto.png"/>
+          <p:cNvPicPr>
+            <a:picLocks noChangeAspect="1"/>
+          </p:cNvPicPr>
+          <p:nvPr/>
+        </p:nvPicPr>
+        <p:blipFill>
+          <a:blip r:embed="rId2"/>
+          <a:stretch>
+            <a:fillRect/>
+          </a:stretch>
+        </p:blipFill>
+        <p:spPr>
+          <a:xfrm>
+            <a:off x="548640" y="1280160"/>
+            <a:ext cx="7132320" cy="3059479"/>
+          </a:xfrm>
+          <a:prstGeom prst="rect">
+            <a:avLst/>
+          </a:prstGeom>
+        </p:spPr>
+      </p:pic>
+      <p:sp>
+        <p:nvSpPr>
+          <p:cNvPr id="8" name="Rounded Rectangle 7"/>
+          <p:cNvSpPr/>
+          <p:nvPr/>
+        </p:nvSpPr>
+        <p:spPr>
+          <a:xfrm>
+            <a:off x="7863840" y="1280160"/>
+            <a:ext cx="3749039" cy="4754880"/>
+          </a:xfrm>
+          <a:prstGeom prst="roundRect">
+            <a:avLst/>
+          </a:prstGeom>
+          <a:solidFill>
+            <a:srgbClr val="EEF1F5"/>
+          </a:solidFill>
+          <a:ln w="12700">
+            <a:solidFill>
+              <a:srgbClr val="D0D7DE"/>
+            </a:solidFill>
+          </a:ln>
+        </p:spPr>
+        <p:style>
+          <a:lnRef idx="1">
+            <a:schemeClr val="accent1"/>
+          </a:lnRef>
+          <a:fillRef idx="3">
+            <a:schemeClr val="accent1"/>
+          </a:fillRef>
+          <a:effectRef idx="2">
+            <a:schemeClr val="accent1"/>
+          </a:effectRef>
+          <a:fontRef idx="minor">
+            <a:schemeClr val="lt1"/>
+          </a:fontRef>
+        </p:style>
+        <p:txBody>
+          <a:bodyPr rtlCol="0" anchor="ctr" wrap="square" lIns="182880" rIns="182880" tIns="182880" bIns="182880"/>
+          <a:lstStyle/>
+          <a:p>
+            <a:pPr algn="ctr">
+              <a:spcAft>
+                <a:spcPts val="800"/>
+              </a:spcAft>
+              <a:defRPr sz="1400" b="1">
+                <a:solidFill>
+                  <a:srgbClr val="A50034"/>
+                </a:solidFill>
+              </a:defRPr>
+            </a:pPr>
+            <a:r>
+              <a:t>⚠️ Cenário de Inconsistência</a:t>
+            </a:r>
+          </a:p>
+          <a:p>
+            <a:pPr>
+              <a:spcAft>
+                <a:spcPts val="600"/>
+              </a:spcAft>
+            </a:pPr>
+            <a:r>
+              <a:rPr b="1" sz="1100">
+                <a:solidFill>
+                  <a:srgbClr val="333333"/>
+                </a:solidFill>
+              </a:rPr>
+              <a:t>• Validação Documental: </a:t>
+            </a:r>
+            <a:r>
+              <a:rPr sz="1100">
+                <a:solidFill>
+                  <a:srgbClr val="333333"/>
+                </a:solidFill>
+              </a:rPr>
+              <a:t>Reprovado por Pendência.</a:t>
+            </a:r>
+          </a:p>
+          <a:p>
+            <a:pPr>
+              <a:spcAft>
+                <a:spcPts val="600"/>
+              </a:spcAft>
+            </a:pPr>
+            <a:r>
+              <a:rPr b="1" sz="1100">
+                <a:solidFill>
+                  <a:srgbClr val="333333"/>
+                </a:solidFill>
+              </a:rPr>
+              <a:t>• Inconsistência Detectada: </a:t>
+            </a:r>
+            <a:r>
+              <a:rPr sz="1100">
+                <a:solidFill>
+                  <a:srgbClr val="333333"/>
+                </a:solidFill>
+              </a:rPr>
+              <a:t>Ausência de Documento Oficial de Identificação com Foto (RG / CPF) no PDF enviado.</a:t>
+            </a:r>
+          </a:p>
+          <a:p>
+            <a:pPr>
+              <a:spcAft>
+                <a:spcPts val="600"/>
+              </a:spcAft>
+            </a:pPr>
+            <a:r>
+              <a:rPr b="1" sz="1100">
+                <a:solidFill>
+                  <a:srgbClr val="333333"/>
+                </a:solidFill>
+              </a:rPr>
+              <a:t>• Gestão de Arquivos: </a:t>
+            </a:r>
+            <a:r>
+              <a:rPr sz="1100">
+                <a:solidFill>
+                  <a:srgbClr val="333333"/>
+                </a:solidFill>
+              </a:rPr>
+              <a:t>PDF retido e movido para a pasta 'Documentos_Pendentes' no ERP local e no Google Drive.</a:t>
+            </a:r>
+          </a:p>
+          <a:p>
+            <a:pPr>
+              <a:spcAft>
+                <a:spcPts val="600"/>
+              </a:spcAft>
+            </a:pPr>
+            <a:r>
+              <a:rPr b="1" sz="1100">
+                <a:solidFill>
+                  <a:srgbClr val="333333"/>
+                </a:solidFill>
+              </a:rPr>
+              <a:t>• Notificação Automática: </a:t>
+            </a:r>
+            <a:r>
+              <a:rPr sz="1100">
+                <a:solidFill>
+                  <a:srgbClr val="333333"/>
+                </a:solidFill>
+              </a:rPr>
+              <a:t>Disparo imediato de e-mail em HTML orientando o cliente sobre o reenvio exato da identidade com foto.</a:t>
+            </a:r>
+          </a:p>
+        </p:txBody>
+      </p:sp>
+      <p:sp>
+        <p:nvSpPr>
+          <p:cNvPr id="9" name="TextBox 8"/>
+          <p:cNvSpPr txBox="1"/>
+          <p:nvPr/>
+        </p:nvSpPr>
+        <p:spPr>
+          <a:xfrm>
+            <a:off x="457200" y="6400800"/>
+            <a:ext cx="11277295" cy="365760"/>
+          </a:xfrm>
+          <a:prstGeom prst="rect">
+            <a:avLst/>
+          </a:prstGeom>
+          <a:noFill/>
+        </p:spPr>
+        <p:txBody>
+          <a:bodyPr wrap="none">
+            <a:spAutoFit/>
+          </a:bodyPr>
+          <a:lstStyle/>
+          <a:p>
+            <a:pPr>
+              <a:defRPr sz="900">
+                <a:solidFill>
+                  <a:srgbClr val="666666"/>
+                </a:solidFill>
+              </a:defRPr>
+            </a:pPr>
+            <a:r>
+              <a:t>Empresa Portal Fake — Processo 1 (Setor de Atendimento) | Técnicas de Hyperautomation (LG / IFAM / FAEPI) | Slide 20 de 23</a:t>
+            </a:r>
+          </a:p>
+        </p:txBody>
+      </p:sp>
+    </p:spTree>
+  </p:cSld>
+  <p:clrMapOvr>
+    <a:masterClrMapping/>
+  </p:clrMapOvr>
+</p:sld>
+</file>
+
+<file path=ppt/slides/slide21.xml><?xml version="1.0" encoding="utf-8"?>
+<p:sld xmlns:a="http://schemas.openxmlformats.org/drawingml/2006/main" xmlns:p="http://schemas.openxmlformats.org/presentationml/2006/main" xmlns:r="http://schemas.openxmlformats.org/officeDocument/2006/relationships">
+  <p:cSld>
+    <p:bg>
+      <p:bgPr>
+        <a:solidFill>
+          <a:srgbClr val="F8F9FA"/>
+        </a:solidFill>
+        <a:effectLst/>
+      </p:bgPr>
+    </p:bg>
+    <p:spTree>
+      <p:nvGrpSpPr>
+        <p:cNvPr id="1" name=""/>
+        <p:cNvGrpSpPr/>
+        <p:nvPr/>
+      </p:nvGrpSpPr>
+      <p:grpSpPr/>
+      <p:sp>
+        <p:nvSpPr>
+          <p:cNvPr id="2" name="Rectangle 1"/>
+          <p:cNvSpPr/>
+          <p:nvPr/>
+        </p:nvSpPr>
+        <p:spPr>
+          <a:xfrm>
+            <a:off x="0" y="0"/>
+            <a:ext cx="12191695" cy="1005840"/>
+          </a:xfrm>
+          <a:prstGeom prst="rect">
+            <a:avLst/>
+          </a:prstGeom>
+          <a:solidFill>
+            <a:srgbClr val="FFFFFF"/>
+          </a:solidFill>
+          <a:ln w="12700">
+            <a:solidFill>
+              <a:srgbClr val="D0D7DE"/>
+            </a:solidFill>
+          </a:ln>
+        </p:spPr>
+        <p:style>
+          <a:lnRef idx="1">
+            <a:schemeClr val="accent1"/>
+          </a:lnRef>
+          <a:fillRef idx="3">
+            <a:schemeClr val="accent1"/>
+          </a:fillRef>
+          <a:effectRef idx="2">
+            <a:schemeClr val="accent1"/>
+          </a:effectRef>
+          <a:fontRef idx="minor">
+            <a:schemeClr val="lt1"/>
+          </a:fontRef>
+        </p:style>
+        <p:txBody>
+          <a:bodyPr rtlCol="0" anchor="ctr"/>
+          <a:lstStyle/>
+          <a:p>
+            <a:pPr algn="ctr"/>
+          </a:p>
+        </p:txBody>
+      </p:sp>
+      <p:sp>
+        <p:nvSpPr>
+          <p:cNvPr id="3" name="Rectangle 2"/>
+          <p:cNvSpPr/>
+          <p:nvPr/>
+        </p:nvSpPr>
+        <p:spPr>
+          <a:xfrm>
+            <a:off x="457200" y="182880"/>
+            <a:ext cx="109728" cy="640080"/>
+          </a:xfrm>
+          <a:prstGeom prst="rect">
+            <a:avLst/>
+          </a:prstGeom>
+          <a:solidFill>
+            <a:srgbClr val="A50034"/>
+          </a:solidFill>
+          <a:ln>
+            <a:noFill/>
+          </a:ln>
+        </p:spPr>
+        <p:style>
+          <a:lnRef idx="1">
+            <a:schemeClr val="accent1"/>
+          </a:lnRef>
+          <a:fillRef idx="3">
+            <a:schemeClr val="accent1"/>
+          </a:fillRef>
+          <a:effectRef idx="2">
+            <a:schemeClr val="accent1"/>
+          </a:effectRef>
+          <a:fontRef idx="minor">
+            <a:schemeClr val="lt1"/>
+          </a:fontRef>
+        </p:style>
+        <p:txBody>
+          <a:bodyPr rtlCol="0" anchor="ctr"/>
+          <a:lstStyle/>
+          <a:p>
+            <a:pPr algn="ctr"/>
+          </a:p>
+        </p:txBody>
+      </p:sp>
+      <p:sp>
+        <p:nvSpPr>
+          <p:cNvPr id="4" name="TextBox 3"/>
+          <p:cNvSpPr txBox="1"/>
+          <p:nvPr/>
+        </p:nvSpPr>
+        <p:spPr>
+          <a:xfrm>
+            <a:off x="685800" y="137160"/>
+            <a:ext cx="8229600" cy="274320"/>
+          </a:xfrm>
+          <a:prstGeom prst="rect">
+            <a:avLst/>
+          </a:prstGeom>
+          <a:noFill/>
+        </p:spPr>
+        <p:txBody>
+          <a:bodyPr wrap="square">
+            <a:spAutoFit/>
+          </a:bodyPr>
+          <a:lstStyle/>
+          <a:p>
+            <a:pPr>
+              <a:defRPr sz="1000" b="1">
+                <a:solidFill>
+                  <a:srgbClr val="A50034"/>
+                </a:solidFill>
+              </a:defRPr>
+            </a:pPr>
+            <a:r>
+              <a:t>BLOCO 4 — DEMONSTRAÇÃO &amp; RESULTADOS</a:t>
+            </a:r>
+          </a:p>
+        </p:txBody>
+      </p:sp>
+      <p:sp>
+        <p:nvSpPr>
+          <p:cNvPr id="5" name="TextBox 4"/>
+          <p:cNvSpPr txBox="1"/>
+          <p:nvPr/>
+        </p:nvSpPr>
+        <p:spPr>
+          <a:xfrm>
+            <a:off x="685800" y="365760"/>
+            <a:ext cx="8229600" cy="548640"/>
+          </a:xfrm>
+          <a:prstGeom prst="rect">
+            <a:avLst/>
+          </a:prstGeom>
+          <a:noFill/>
+        </p:spPr>
+        <p:txBody>
+          <a:bodyPr wrap="square">
+            <a:spAutoFit/>
+          </a:bodyPr>
+          <a:lstStyle/>
+          <a:p>
+            <a:pPr>
+              <a:defRPr sz="2000" b="1">
+                <a:solidFill>
+                  <a:srgbClr val="333333"/>
+                </a:solidFill>
+              </a:defRPr>
+            </a:pPr>
+            <a:r>
+              <a:t>Evidência 3: Pendência — Falta Comprovante de Residência</a:t>
+            </a:r>
+          </a:p>
+        </p:txBody>
+      </p:sp>
+      <p:sp>
+        <p:nvSpPr>
+          <p:cNvPr id="6" name="Rounded Rectangle 5"/>
+          <p:cNvSpPr/>
+          <p:nvPr/>
+        </p:nvSpPr>
+        <p:spPr>
+          <a:xfrm>
+            <a:off x="8961120" y="274320"/>
+            <a:ext cx="2743200" cy="457200"/>
+          </a:xfrm>
+          <a:prstGeom prst="roundRect">
+            <a:avLst/>
+          </a:prstGeom>
+          <a:solidFill>
+            <a:srgbClr val="A50034"/>
+          </a:solidFill>
+          <a:ln>
+            <a:noFill/>
+          </a:ln>
+        </p:spPr>
+        <p:style>
+          <a:lnRef idx="1">
+            <a:schemeClr val="accent1"/>
+          </a:lnRef>
+          <a:fillRef idx="3">
+            <a:schemeClr val="accent1"/>
+          </a:fillRef>
+          <a:effectRef idx="2">
+            <a:schemeClr val="accent1"/>
+          </a:effectRef>
+          <a:fontRef idx="minor">
+            <a:schemeClr val="lt1"/>
+          </a:fontRef>
+        </p:style>
+        <p:txBody>
+          <a:bodyPr rtlCol="0" anchor="ctr"/>
+          <a:lstStyle/>
+          <a:p>
+            <a:pPr algn="ctr">
+              <a:defRPr sz="1100" b="1">
+                <a:solidFill>
+                  <a:srgbClr val="FFFFFF"/>
+                </a:solidFill>
+              </a:defRPr>
+            </a:pPr>
+            <a:r>
+              <a:t>Equipe Integrada</a:t>
+            </a:r>
+          </a:p>
+        </p:txBody>
+      </p:sp>
+      <p:pic>
+        <p:nvPicPr>
+          <p:cNvPr id="7" name="Picture 6" descr="falha_falta-comprovante-residencia.png"/>
+          <p:cNvPicPr>
+            <a:picLocks noChangeAspect="1"/>
+          </p:cNvPicPr>
+          <p:nvPr/>
+        </p:nvPicPr>
+        <p:blipFill>
+          <a:blip r:embed="rId2"/>
+          <a:stretch>
+            <a:fillRect/>
+          </a:stretch>
+        </p:blipFill>
+        <p:spPr>
+          <a:xfrm>
+            <a:off x="548640" y="1280160"/>
+            <a:ext cx="7132320" cy="3059479"/>
+          </a:xfrm>
+          <a:prstGeom prst="rect">
+            <a:avLst/>
+          </a:prstGeom>
+        </p:spPr>
+      </p:pic>
+      <p:sp>
+        <p:nvSpPr>
+          <p:cNvPr id="8" name="Rounded Rectangle 7"/>
+          <p:cNvSpPr/>
+          <p:nvPr/>
+        </p:nvSpPr>
+        <p:spPr>
+          <a:xfrm>
+            <a:off x="7863840" y="1280160"/>
+            <a:ext cx="3749039" cy="4754880"/>
+          </a:xfrm>
+          <a:prstGeom prst="roundRect">
+            <a:avLst/>
+          </a:prstGeom>
+          <a:solidFill>
+            <a:srgbClr val="EEF1F5"/>
+          </a:solidFill>
+          <a:ln w="12700">
+            <a:solidFill>
+              <a:srgbClr val="D0D7DE"/>
+            </a:solidFill>
+          </a:ln>
+        </p:spPr>
+        <p:style>
+          <a:lnRef idx="1">
+            <a:schemeClr val="accent1"/>
+          </a:lnRef>
+          <a:fillRef idx="3">
+            <a:schemeClr val="accent1"/>
+          </a:fillRef>
+          <a:effectRef idx="2">
+            <a:schemeClr val="accent1"/>
+          </a:effectRef>
+          <a:fontRef idx="minor">
+            <a:schemeClr val="lt1"/>
+          </a:fontRef>
+        </p:style>
+        <p:txBody>
+          <a:bodyPr rtlCol="0" anchor="ctr" wrap="square" lIns="182880" rIns="182880" tIns="182880" bIns="182880"/>
+          <a:lstStyle/>
+          <a:p>
+            <a:pPr algn="ctr">
+              <a:spcAft>
+                <a:spcPts val="800"/>
+              </a:spcAft>
+              <a:defRPr sz="1400" b="1">
+                <a:solidFill>
+                  <a:srgbClr val="A50034"/>
+                </a:solidFill>
+              </a:defRPr>
+            </a:pPr>
+            <a:r>
+              <a:t>⚠️ Cenário de Inconsistência</a:t>
+            </a:r>
+          </a:p>
+          <a:p>
+            <a:pPr>
+              <a:spcAft>
+                <a:spcPts val="600"/>
+              </a:spcAft>
+            </a:pPr>
+            <a:r>
+              <a:rPr b="1" sz="1100">
+                <a:solidFill>
+                  <a:srgbClr val="333333"/>
+                </a:solidFill>
+              </a:rPr>
+              <a:t>• Validação Documental: </a:t>
+            </a:r>
+            <a:r>
+              <a:rPr sz="1100">
+                <a:solidFill>
+                  <a:srgbClr val="333333"/>
+                </a:solidFill>
+              </a:rPr>
+              <a:t>Reprovado por Pendência.</a:t>
+            </a:r>
+          </a:p>
+          <a:p>
+            <a:pPr>
+              <a:spcAft>
+                <a:spcPts val="600"/>
+              </a:spcAft>
+            </a:pPr>
+            <a:r>
+              <a:rPr b="1" sz="1100">
+                <a:solidFill>
+                  <a:srgbClr val="333333"/>
+                </a:solidFill>
+              </a:rPr>
+              <a:t>• Inconsistência Detectada: </a:t>
+            </a:r>
+            <a:r>
+              <a:rPr sz="1100">
+                <a:solidFill>
+                  <a:srgbClr val="333333"/>
+                </a:solidFill>
+              </a:rPr>
+              <a:t>Ausência do Comprovante de Residência (fatura de água/luz/endereço) no PDF retornado.</a:t>
+            </a:r>
+          </a:p>
+          <a:p>
+            <a:pPr>
+              <a:spcAft>
+                <a:spcPts val="600"/>
+              </a:spcAft>
+            </a:pPr>
+            <a:r>
+              <a:rPr b="1" sz="1100">
+                <a:solidFill>
+                  <a:srgbClr val="333333"/>
+                </a:solidFill>
+              </a:rPr>
+              <a:t>• Gestão de Arquivos: </a:t>
+            </a:r>
+            <a:r>
+              <a:rPr sz="1100">
+                <a:solidFill>
+                  <a:srgbClr val="333333"/>
+                </a:solidFill>
+              </a:rPr>
+              <a:t>PDF movido para 'Documentos_Pendentes' no ERP e espelhado no Google Drive.</a:t>
+            </a:r>
+          </a:p>
+          <a:p>
+            <a:pPr>
+              <a:spcAft>
+                <a:spcPts val="600"/>
+              </a:spcAft>
+            </a:pPr>
+            <a:r>
+              <a:rPr b="1" sz="1100">
+                <a:solidFill>
+                  <a:srgbClr val="333333"/>
+                </a:solidFill>
+              </a:rPr>
+              <a:t>• Notificação Automática: </a:t>
+            </a:r>
+            <a:r>
+              <a:rPr sz="1100">
+                <a:solidFill>
+                  <a:srgbClr val="333333"/>
+                </a:solidFill>
+              </a:rPr>
+              <a:t>Envio de e-mail em HTML responsivo solicitando a regularização do comprovante residencial.</a:t>
+            </a:r>
+          </a:p>
+        </p:txBody>
+      </p:sp>
+      <p:sp>
+        <p:nvSpPr>
+          <p:cNvPr id="9" name="TextBox 8"/>
+          <p:cNvSpPr txBox="1"/>
+          <p:nvPr/>
+        </p:nvSpPr>
+        <p:spPr>
+          <a:xfrm>
+            <a:off x="457200" y="6400800"/>
+            <a:ext cx="11277295" cy="365760"/>
+          </a:xfrm>
+          <a:prstGeom prst="rect">
+            <a:avLst/>
+          </a:prstGeom>
+          <a:noFill/>
+        </p:spPr>
+        <p:txBody>
+          <a:bodyPr wrap="none">
+            <a:spAutoFit/>
+          </a:bodyPr>
+          <a:lstStyle/>
+          <a:p>
+            <a:pPr>
+              <a:defRPr sz="900">
+                <a:solidFill>
+                  <a:srgbClr val="666666"/>
+                </a:solidFill>
+              </a:defRPr>
+            </a:pPr>
+            <a:r>
+              <a:t>Empresa Portal Fake — Processo 1 (Setor de Atendimento) | Técnicas de Hyperautomation (LG / IFAM / FAEPI) | Slide 21 de 23</a:t>
+            </a:r>
+          </a:p>
+        </p:txBody>
+      </p:sp>
+    </p:spTree>
+  </p:cSld>
+  <p:clrMapOvr>
+    <a:masterClrMapping/>
+  </p:clrMapOvr>
+</p:sld>
+</file>
+
+<file path=ppt/slides/slide22.xml><?xml version="1.0" encoding="utf-8"?>
 <p:sld xmlns:a="http://schemas.openxmlformats.org/drawingml/2006/main" xmlns:p="http://schemas.openxmlformats.org/presentationml/2006/main" xmlns:r="http://schemas.openxmlformats.org/officeDocument/2006/relationships">
   <p:cSld>
     <p:bg>
@@ -9839,7 +10613,7 @@
               </a:defRPr>
             </a:pPr>
             <a:r>
-              <a:t>Empresa Portal Fake — Processo 1 (Setor de Atendimento) | Técnicas de Hyperautomation (LG / IFAM / FAEPI) | Slide 20 de 21</a:t>
+              <a:t>Empresa Portal Fake — Processo 1 (Setor de Atendimento) | Técnicas de Hyperautomation (LG / IFAM / FAEPI) | Slide 22 de 23</a:t>
             </a:r>
           </a:p>
         </p:txBody>
@@ -9852,7 +10626,7 @@
 </p:sld>
 </file>
 
-<file path=ppt/slides/slide21.xml><?xml version="1.0" encoding="utf-8"?>
+<file path=ppt/slides/slide23.xml><?xml version="1.0" encoding="utf-8"?>
 <p:sld xmlns:a="http://schemas.openxmlformats.org/drawingml/2006/main" xmlns:p="http://schemas.openxmlformats.org/presentationml/2006/main" xmlns:r="http://schemas.openxmlformats.org/officeDocument/2006/relationships">
   <p:cSld>
     <p:bg>
@@ -10431,7 +11205,7 @@
               </a:defRPr>
             </a:pPr>
             <a:r>
-              <a:t>Empresa Portal Fake — Processo 1 (Setor de Atendimento) | Técnicas de Hyperautomation (LG / IFAM / FAEPI) | Slide 21 de 21</a:t>
+              <a:t>Empresa Portal Fake — Processo 1 (Setor de Atendimento) | Técnicas de Hyperautomation (LG / IFAM / FAEPI) | Slide 23 de 23</a:t>
             </a:r>
           </a:p>
         </p:txBody>

</xml_diff>

<commit_message>
docs: criados 5 slides dedicados em tela cheia para cada evidencia (screenshots e emails)
</commit_message>
<xml_diff>
--- a/docs/Apresentacao_Hyperautomation_Processo1_LG.pptx
+++ b/docs/Apresentacao_Hyperautomation_Processo1_LG.pptx
@@ -28,6 +28,7 @@
     <p:sldId id="276" r:id="rId27"/>
     <p:sldId id="277" r:id="rId28"/>
     <p:sldId id="278" r:id="rId29"/>
+    <p:sldId id="279" r:id="rId30"/>
   </p:sldIdLst>
   <p:sldSz cx="12191695" cy="6858000" type="screen4x3"/>
   <p:notesSz cx="6858000" cy="9144000"/>
@@ -7411,7 +7412,7 @@
               </a:defRPr>
             </a:pPr>
             <a:r>
-              <a:t>Evidências Práticas: Portal Fake &amp; Google Drive</a:t>
+              <a:t>Evidência 1: Interface Web do Portal Fake ERP (Preenchimento RPA)</a:t>
             </a:r>
           </a:p>
         </p:txBody>
@@ -7476,8 +7477,8 @@
         </p:nvSpPr>
         <p:spPr>
           <a:xfrm>
-            <a:off x="548640" y="4754880"/>
-            <a:ext cx="5303520" cy="1280160"/>
+            <a:off x="7863840" y="1280160"/>
+            <a:ext cx="3749039" cy="4754880"/>
           </a:xfrm>
           <a:prstGeom prst="roundRect">
             <a:avLst/>
@@ -7520,7 +7521,7 @@
               </a:defRPr>
             </a:pPr>
             <a:r>
-              <a:t>Figura 2: Portal ERP Preenchido</a:t>
+              <a:t>🤖 Automação Web Playwright</a:t>
             </a:r>
           </a:p>
           <a:p>
@@ -7535,7 +7536,7 @@
                   <a:srgbClr val="333333"/>
                 </a:solidFill>
               </a:rPr>
-              <a:t>• Playwright RPA: </a:t>
+              <a:t>• Interface do Portal ERP: </a:t>
             </a:r>
             <a:r>
               <a:rPr sz="1100">
@@ -7543,64 +7544,7 @@
                   <a:srgbClr val="333333"/>
                 </a:solidFill>
               </a:rPr>
-              <a:t>Cadastros preenchidos automaticamente na interface web.</a:t>
-            </a:r>
-          </a:p>
-        </p:txBody>
-      </p:sp>
-      <p:sp>
-        <p:nvSpPr>
-          <p:cNvPr id="8" name="Rounded Rectangle 7"/>
-          <p:cNvSpPr/>
-          <p:nvPr/>
-        </p:nvSpPr>
-        <p:spPr>
-          <a:xfrm>
-            <a:off x="6217920" y="4754880"/>
-            <a:ext cx="5303520" cy="1280160"/>
-          </a:xfrm>
-          <a:prstGeom prst="roundRect">
-            <a:avLst/>
-          </a:prstGeom>
-          <a:solidFill>
-            <a:srgbClr val="EEF1F5"/>
-          </a:solidFill>
-          <a:ln w="12700">
-            <a:solidFill>
-              <a:srgbClr val="D0D7DE"/>
-            </a:solidFill>
-          </a:ln>
-        </p:spPr>
-        <p:style>
-          <a:lnRef idx="1">
-            <a:schemeClr val="accent1"/>
-          </a:lnRef>
-          <a:fillRef idx="3">
-            <a:schemeClr val="accent1"/>
-          </a:fillRef>
-          <a:effectRef idx="2">
-            <a:schemeClr val="accent1"/>
-          </a:effectRef>
-          <a:fontRef idx="minor">
-            <a:schemeClr val="lt1"/>
-          </a:fontRef>
-        </p:style>
-        <p:txBody>
-          <a:bodyPr rtlCol="0" anchor="ctr" wrap="square" lIns="182880" rIns="182880" tIns="182880" bIns="182880"/>
-          <a:lstStyle/>
-          <a:p>
-            <a:pPr algn="ctr">
-              <a:spcAft>
-                <a:spcPts val="800"/>
-              </a:spcAft>
-              <a:defRPr sz="1400" b="1">
-                <a:solidFill>
-                  <a:srgbClr val="A50034"/>
-                </a:solidFill>
-              </a:defRPr>
-            </a:pPr>
-            <a:r>
-              <a:t>Figura 3: Ativação de Cadastro</a:t>
+              <a:t>Visão geral da tabela de cadastros mantida no Portal Fake Soluções Digitais.</a:t>
             </a:r>
           </a:p>
           <a:p>
@@ -7615,7 +7559,7 @@
                   <a:srgbClr val="333333"/>
                 </a:solidFill>
               </a:rPr>
-              <a:t>• Status Ativo: </a:t>
+              <a:t>• Execução de Alta Velocidade: </a:t>
             </a:r>
             <a:r>
               <a:rPr sz="1100">
@@ -7623,14 +7567,60 @@
                   <a:srgbClr val="333333"/>
                 </a:solidFill>
               </a:rPr>
-              <a:t>Confirmação do cadastro ativado com sucesso após validação.</a:t>
-            </a:r>
-          </a:p>
-        </p:txBody>
-      </p:sp>
-      <p:sp>
-        <p:nvSpPr>
-          <p:cNvPr id="9" name="TextBox 8"/>
+              <a:t>Preenchimento e sincronização dinâmica em massa executados via Chromium Headless.</a:t>
+            </a:r>
+          </a:p>
+          <a:p>
+            <a:pPr>
+              <a:spcAft>
+                <a:spcPts val="600"/>
+              </a:spcAft>
+            </a:pPr>
+            <a:r>
+              <a:rPr b="1" sz="1100">
+                <a:solidFill>
+                  <a:srgbClr val="333333"/>
+                </a:solidFill>
+              </a:rPr>
+              <a:t>• Validação em Tela: </a:t>
+            </a:r>
+            <a:r>
+              <a:rPr sz="1100">
+                <a:solidFill>
+                  <a:srgbClr val="333333"/>
+                </a:solidFill>
+              </a:rPr>
+              <a:t>Verificação de campos obrigatórios e integridade das linhas de cadastro.</a:t>
+            </a:r>
+          </a:p>
+          <a:p>
+            <a:pPr>
+              <a:spcAft>
+                <a:spcPts val="600"/>
+              </a:spcAft>
+            </a:pPr>
+            <a:r>
+              <a:rPr b="1" sz="1100">
+                <a:solidFill>
+                  <a:srgbClr val="333333"/>
+                </a:solidFill>
+              </a:rPr>
+              <a:t>• Rastreabilidade: </a:t>
+            </a:r>
+            <a:r>
+              <a:rPr sz="1100">
+                <a:solidFill>
+                  <a:srgbClr val="333333"/>
+                </a:solidFill>
+              </a:rPr>
+              <a:t>Captura de tela automatizada no encerramento da carga inicial do sistema.</a:t>
+            </a:r>
+          </a:p>
+        </p:txBody>
+      </p:sp>
+      <p:sp>
+        <p:nvSpPr>
+          <p:cNvPr id="8" name="TextBox 7"/>
           <p:cNvSpPr txBox="1"/>
           <p:nvPr/>
         </p:nvSpPr>
@@ -7658,7 +7648,7 @@
               </a:defRPr>
             </a:pPr>
             <a:r>
-              <a:t>Empresa Portal Fake — Processo 1 (Setor de Atendimento) | Técnicas de Hyperautomation (LG / IFAM / FAEPI) | Slide 18 de 20</a:t>
+              <a:t>Empresa Portal Fake — Processo 1 (Setor de Atendimento) | Técnicas de Hyperautomation (LG / IFAM / FAEPI) | Slide 18 de 24</a:t>
             </a:r>
           </a:p>
         </p:txBody>
@@ -7842,7 +7832,7 @@
               </a:defRPr>
             </a:pPr>
             <a:r>
-              <a:t>Evidência 1: Confirmação de Cadastro Aprovado (E-mail HTML)</a:t>
+              <a:t>Evidência 2: Formulário e Ativação de Cadastro no ERP</a:t>
             </a:r>
           </a:p>
         </p:txBody>
@@ -7899,33 +7889,9 @@
           </a:p>
         </p:txBody>
       </p:sp>
-      <p:pic>
-        <p:nvPicPr>
-          <p:cNvPr id="7" name="Picture 6" descr="sucesso.png"/>
-          <p:cNvPicPr>
-            <a:picLocks noChangeAspect="1"/>
-          </p:cNvPicPr>
-          <p:nvPr/>
-        </p:nvPicPr>
-        <p:blipFill>
-          <a:blip r:embed="rId2"/>
-          <a:stretch>
-            <a:fillRect/>
-          </a:stretch>
-        </p:blipFill>
-        <p:spPr>
-          <a:xfrm>
-            <a:off x="548640" y="1280160"/>
-            <a:ext cx="7132320" cy="3059479"/>
-          </a:xfrm>
-          <a:prstGeom prst="rect">
-            <a:avLst/>
-          </a:prstGeom>
-        </p:spPr>
-      </p:pic>
-      <p:sp>
-        <p:nvSpPr>
-          <p:cNvPr id="8" name="Rounded Rectangle 7"/>
+      <p:sp>
+        <p:nvSpPr>
+          <p:cNvPr id="7" name="Rounded Rectangle 6"/>
           <p:cNvSpPr/>
           <p:nvPr/>
         </p:nvSpPr>
@@ -7975,7 +7941,7 @@
               </a:defRPr>
             </a:pPr>
             <a:r>
-              <a:t>✅ Cenário de Sucesso</a:t>
+              <a:t>✅ Ativação de Cadastro</a:t>
             </a:r>
           </a:p>
           <a:p>
@@ -7990,7 +7956,7 @@
                   <a:srgbClr val="333333"/>
                 </a:solidFill>
               </a:rPr>
-              <a:t>• Validação Documental: </a:t>
+              <a:t>• Modal de Novo Cadastro: </a:t>
             </a:r>
             <a:r>
               <a:rPr sz="1100">
@@ -7998,7 +7964,7 @@
                   <a:srgbClr val="333333"/>
                 </a:solidFill>
               </a:rPr>
-              <a:t>100% Aprovado.</a:t>
+              <a:t>Formulário cadastral preenchido automaticamente com os dados extraídos do cliente.</a:t>
             </a:r>
           </a:p>
           <a:p>
@@ -8013,7 +7979,7 @@
                   <a:srgbClr val="333333"/>
                 </a:solidFill>
               </a:rPr>
-              <a:t>• Análise do PDF: </a:t>
+              <a:t>• Transição de Status: </a:t>
             </a:r>
             <a:r>
               <a:rPr sz="1100">
@@ -8021,7 +7987,7 @@
                   <a:srgbClr val="333333"/>
                 </a:solidFill>
               </a:rPr>
-              <a:t>Ficha Cadastral Assinada, Documento com Foto e Comprovante de Residência validados via pypdf.</a:t>
+              <a:t>Cliente ativado no ERP com a transição automática do estado para 'ATIVO' após validação documental.</a:t>
             </a:r>
           </a:p>
           <a:p>
@@ -8036,7 +8002,7 @@
                   <a:srgbClr val="333333"/>
                 </a:solidFill>
               </a:rPr>
-              <a:t>• Automação Web: </a:t>
+              <a:t>• Registro de Atendimento: </a:t>
             </a:r>
             <a:r>
               <a:rPr sz="1100">
@@ -8044,7 +8010,7 @@
                   <a:srgbClr val="333333"/>
                 </a:solidFill>
               </a:rPr>
-              <a:t>Cadastro ativado no Portal Fake ERP como 'ATIVO' via Playwright.</a:t>
+              <a:t>Inclusão de observações auditáveis informando o atendimento automatizado.</a:t>
             </a:r>
           </a:p>
           <a:p>
@@ -8059,7 +8025,7 @@
                   <a:srgbClr val="333333"/>
                 </a:solidFill>
               </a:rPr>
-              <a:t>• Gestão de Arquivos: </a:t>
+              <a:t>• Screenshot de Evidência: </a:t>
             </a:r>
             <a:r>
               <a:rPr sz="1100">
@@ -8067,37 +8033,14 @@
                   <a:srgbClr val="333333"/>
                 </a:solidFill>
               </a:rPr>
-              <a:t>Arquivo transferido para 'Documentos_OK' e depois 'Encaminhados' (local e Google Drive).</a:t>
-            </a:r>
-          </a:p>
-          <a:p>
-            <a:pPr>
-              <a:spcAft>
-                <a:spcPts val="600"/>
-              </a:spcAft>
-            </a:pPr>
-            <a:r>
-              <a:rPr b="1" sz="1100">
-                <a:solidFill>
-                  <a:srgbClr val="333333"/>
-                </a:solidFill>
-              </a:rPr>
-              <a:t>• Notificação: </a:t>
-            </a:r>
-            <a:r>
-              <a:rPr sz="1100">
-                <a:solidFill>
-                  <a:srgbClr val="333333"/>
-                </a:solidFill>
-              </a:rPr>
-              <a:t>Disparo instantâneo do e-mail em HTML responsivo com protocolo único de aprovação.</a:t>
-            </a:r>
-          </a:p>
-        </p:txBody>
-      </p:sp>
-      <p:sp>
-        <p:nvSpPr>
-          <p:cNvPr id="9" name="TextBox 8"/>
+              <a:t>Registro armazenado e enviado como artefato ao BotCity Maestro.</a:t>
+            </a:r>
+          </a:p>
+        </p:txBody>
+      </p:sp>
+      <p:sp>
+        <p:nvSpPr>
+          <p:cNvPr id="8" name="TextBox 7"/>
           <p:cNvSpPr txBox="1"/>
           <p:nvPr/>
         </p:nvSpPr>
@@ -8125,7 +8068,7 @@
               </a:defRPr>
             </a:pPr>
             <a:r>
-              <a:t>Empresa Portal Fake — Processo 1 (Setor de Atendimento) | Técnicas de Hyperautomation (LG / IFAM / FAEPI) | Slide 19 de 23</a:t>
+              <a:t>Empresa Portal Fake — Processo 1 (Setor de Atendimento) | Técnicas de Hyperautomation (LG / IFAM / FAEPI) | Slide 19 de 24</a:t>
             </a:r>
           </a:p>
         </p:txBody>
@@ -9176,7 +9119,7 @@
               </a:defRPr>
             </a:pPr>
             <a:r>
-              <a:t>Evidência 2: Pendência — Falta Documento Oficial com Foto</a:t>
+              <a:t>Evidência 3: Confirmação de Cadastro Aprovado (E-mail HTML)</a:t>
             </a:r>
           </a:p>
         </p:txBody>
@@ -9235,7 +9178,7 @@
       </p:sp>
       <p:pic>
         <p:nvPicPr>
-          <p:cNvPr id="7" name="Picture 6" descr="falha_faltou_documento_foto.png"/>
+          <p:cNvPr id="7" name="Picture 6" descr="sucesso.png"/>
           <p:cNvPicPr>
             <a:picLocks noChangeAspect="1"/>
           </p:cNvPicPr>
@@ -9309,7 +9252,7 @@
               </a:defRPr>
             </a:pPr>
             <a:r>
-              <a:t>⚠️ Cenário de Inconsistência</a:t>
+              <a:t>✅ E-mail de Aprovação</a:t>
             </a:r>
           </a:p>
           <a:p>
@@ -9332,7 +9275,7 @@
                   <a:srgbClr val="333333"/>
                 </a:solidFill>
               </a:rPr>
-              <a:t>Reprovado por Pendência.</a:t>
+              <a:t>100% Aprovado.</a:t>
             </a:r>
           </a:p>
           <a:p>
@@ -9347,7 +9290,7 @@
                   <a:srgbClr val="333333"/>
                 </a:solidFill>
               </a:rPr>
-              <a:t>• Inconsistência Detectada: </a:t>
+              <a:t>• Análise do PDF: </a:t>
             </a:r>
             <a:r>
               <a:rPr sz="1100">
@@ -9355,7 +9298,7 @@
                   <a:srgbClr val="333333"/>
                 </a:solidFill>
               </a:rPr>
-              <a:t>Ausência de Documento Oficial de Identificação com Foto (RG / CPF) no PDF enviado.</a:t>
+              <a:t>Ficha Cadastral Assinada, Documento com Foto e Comprovante de Residência validados via pypdf.</a:t>
             </a:r>
           </a:p>
           <a:p>
@@ -9370,6 +9313,29 @@
                   <a:srgbClr val="333333"/>
                 </a:solidFill>
               </a:rPr>
+              <a:t>• Automação Web: </a:t>
+            </a:r>
+            <a:r>
+              <a:rPr sz="1100">
+                <a:solidFill>
+                  <a:srgbClr val="333333"/>
+                </a:solidFill>
+              </a:rPr>
+              <a:t>Cadastro ativado no Portal Fake ERP como 'ATIVO' via Playwright.</a:t>
+            </a:r>
+          </a:p>
+          <a:p>
+            <a:pPr>
+              <a:spcAft>
+                <a:spcPts val="600"/>
+              </a:spcAft>
+            </a:pPr>
+            <a:r>
+              <a:rPr b="1" sz="1100">
+                <a:solidFill>
+                  <a:srgbClr val="333333"/>
+                </a:solidFill>
+              </a:rPr>
               <a:t>• Gestão de Arquivos: </a:t>
             </a:r>
             <a:r>
@@ -9378,7 +9344,7 @@
                   <a:srgbClr val="333333"/>
                 </a:solidFill>
               </a:rPr>
-              <a:t>PDF retido e movido para a pasta 'Documentos_Pendentes' no ERP local e no Google Drive.</a:t>
+              <a:t>Arquivo transferido para 'Documentos_OK' e depois 'Encaminhados' (local e Google Drive).</a:t>
             </a:r>
           </a:p>
           <a:p>
@@ -9393,7 +9359,7 @@
                   <a:srgbClr val="333333"/>
                 </a:solidFill>
               </a:rPr>
-              <a:t>• Notificação Automática: </a:t>
+              <a:t>• Notificação: </a:t>
             </a:r>
             <a:r>
               <a:rPr sz="1100">
@@ -9401,7 +9367,7 @@
                   <a:srgbClr val="333333"/>
                 </a:solidFill>
               </a:rPr>
-              <a:t>Disparo imediato de e-mail em HTML orientando o cliente sobre o reenvio exato da identidade com foto.</a:t>
+              <a:t>Disparo instantâneo do e-mail em HTML responsivo com protocolo único de aprovação.</a:t>
             </a:r>
           </a:p>
         </p:txBody>
@@ -9436,7 +9402,7 @@
               </a:defRPr>
             </a:pPr>
             <a:r>
-              <a:t>Empresa Portal Fake — Processo 1 (Setor de Atendimento) | Técnicas de Hyperautomation (LG / IFAM / FAEPI) | Slide 20 de 23</a:t>
+              <a:t>Empresa Portal Fake — Processo 1 (Setor de Atendimento) | Técnicas de Hyperautomation (LG / IFAM / FAEPI) | Slide 20 de 24</a:t>
             </a:r>
           </a:p>
         </p:txBody>
@@ -9620,7 +9586,7 @@
               </a:defRPr>
             </a:pPr>
             <a:r>
-              <a:t>Evidência 3: Pendência — Falta Comprovante de Residência</a:t>
+              <a:t>Evidência 4: Pendência — Falta Documento Oficial com Foto</a:t>
             </a:r>
           </a:p>
         </p:txBody>
@@ -9679,7 +9645,7 @@
       </p:sp>
       <p:pic>
         <p:nvPicPr>
-          <p:cNvPr id="7" name="Picture 6" descr="falha_falta-comprovante-residencia.png"/>
+          <p:cNvPr id="7" name="Picture 6" descr="falha_faltou_documento_foto.png"/>
           <p:cNvPicPr>
             <a:picLocks noChangeAspect="1"/>
           </p:cNvPicPr>
@@ -9753,7 +9719,7 @@
               </a:defRPr>
             </a:pPr>
             <a:r>
-              <a:t>⚠️ Cenário de Inconsistência</a:t>
+              <a:t>⚠️ Pendência: Doc. Foto</a:t>
             </a:r>
           </a:p>
           <a:p>
@@ -9799,7 +9765,7 @@
                   <a:srgbClr val="333333"/>
                 </a:solidFill>
               </a:rPr>
-              <a:t>Ausência do Comprovante de Residência (fatura de água/luz/endereço) no PDF retornado.</a:t>
+              <a:t>Ausência de Documento Oficial de Identificação com Foto (RG / CPF) no PDF enviado.</a:t>
             </a:r>
           </a:p>
           <a:p>
@@ -9822,7 +9788,7 @@
                   <a:srgbClr val="333333"/>
                 </a:solidFill>
               </a:rPr>
-              <a:t>PDF movido para 'Documentos_Pendentes' no ERP e espelhado no Google Drive.</a:t>
+              <a:t>PDF retido e movido para a pasta 'Documentos_Pendentes' no ERP local e no Google Drive.</a:t>
             </a:r>
           </a:p>
           <a:p>
@@ -9845,7 +9811,7 @@
                   <a:srgbClr val="333333"/>
                 </a:solidFill>
               </a:rPr>
-              <a:t>Envio de e-mail em HTML responsivo solicitando a regularização do comprovante residencial.</a:t>
+              <a:t>Disparo imediato de e-mail em HTML orientando o cliente sobre o reenvio exato da identidade com foto.</a:t>
             </a:r>
           </a:p>
         </p:txBody>
@@ -9880,7 +9846,7 @@
               </a:defRPr>
             </a:pPr>
             <a:r>
-              <a:t>Empresa Portal Fake — Processo 1 (Setor de Atendimento) | Técnicas de Hyperautomation (LG / IFAM / FAEPI) | Slide 21 de 23</a:t>
+              <a:t>Empresa Portal Fake — Processo 1 (Setor de Atendimento) | Técnicas de Hyperautomation (LG / IFAM / FAEPI) | Slide 21 de 24</a:t>
             </a:r>
           </a:p>
         </p:txBody>
@@ -9894,6 +9860,450 @@
 </file>
 
 <file path=ppt/slides/slide22.xml><?xml version="1.0" encoding="utf-8"?>
+<p:sld xmlns:a="http://schemas.openxmlformats.org/drawingml/2006/main" xmlns:p="http://schemas.openxmlformats.org/presentationml/2006/main" xmlns:r="http://schemas.openxmlformats.org/officeDocument/2006/relationships">
+  <p:cSld>
+    <p:bg>
+      <p:bgPr>
+        <a:solidFill>
+          <a:srgbClr val="F8F9FA"/>
+        </a:solidFill>
+        <a:effectLst/>
+      </p:bgPr>
+    </p:bg>
+    <p:spTree>
+      <p:nvGrpSpPr>
+        <p:cNvPr id="1" name=""/>
+        <p:cNvGrpSpPr/>
+        <p:nvPr/>
+      </p:nvGrpSpPr>
+      <p:grpSpPr/>
+      <p:sp>
+        <p:nvSpPr>
+          <p:cNvPr id="2" name="Rectangle 1"/>
+          <p:cNvSpPr/>
+          <p:nvPr/>
+        </p:nvSpPr>
+        <p:spPr>
+          <a:xfrm>
+            <a:off x="0" y="0"/>
+            <a:ext cx="12191695" cy="1005840"/>
+          </a:xfrm>
+          <a:prstGeom prst="rect">
+            <a:avLst/>
+          </a:prstGeom>
+          <a:solidFill>
+            <a:srgbClr val="FFFFFF"/>
+          </a:solidFill>
+          <a:ln w="12700">
+            <a:solidFill>
+              <a:srgbClr val="D0D7DE"/>
+            </a:solidFill>
+          </a:ln>
+        </p:spPr>
+        <p:style>
+          <a:lnRef idx="1">
+            <a:schemeClr val="accent1"/>
+          </a:lnRef>
+          <a:fillRef idx="3">
+            <a:schemeClr val="accent1"/>
+          </a:fillRef>
+          <a:effectRef idx="2">
+            <a:schemeClr val="accent1"/>
+          </a:effectRef>
+          <a:fontRef idx="minor">
+            <a:schemeClr val="lt1"/>
+          </a:fontRef>
+        </p:style>
+        <p:txBody>
+          <a:bodyPr rtlCol="0" anchor="ctr"/>
+          <a:lstStyle/>
+          <a:p>
+            <a:pPr algn="ctr"/>
+          </a:p>
+        </p:txBody>
+      </p:sp>
+      <p:sp>
+        <p:nvSpPr>
+          <p:cNvPr id="3" name="Rectangle 2"/>
+          <p:cNvSpPr/>
+          <p:nvPr/>
+        </p:nvSpPr>
+        <p:spPr>
+          <a:xfrm>
+            <a:off x="457200" y="182880"/>
+            <a:ext cx="109728" cy="640080"/>
+          </a:xfrm>
+          <a:prstGeom prst="rect">
+            <a:avLst/>
+          </a:prstGeom>
+          <a:solidFill>
+            <a:srgbClr val="A50034"/>
+          </a:solidFill>
+          <a:ln>
+            <a:noFill/>
+          </a:ln>
+        </p:spPr>
+        <p:style>
+          <a:lnRef idx="1">
+            <a:schemeClr val="accent1"/>
+          </a:lnRef>
+          <a:fillRef idx="3">
+            <a:schemeClr val="accent1"/>
+          </a:fillRef>
+          <a:effectRef idx="2">
+            <a:schemeClr val="accent1"/>
+          </a:effectRef>
+          <a:fontRef idx="minor">
+            <a:schemeClr val="lt1"/>
+          </a:fontRef>
+        </p:style>
+        <p:txBody>
+          <a:bodyPr rtlCol="0" anchor="ctr"/>
+          <a:lstStyle/>
+          <a:p>
+            <a:pPr algn="ctr"/>
+          </a:p>
+        </p:txBody>
+      </p:sp>
+      <p:sp>
+        <p:nvSpPr>
+          <p:cNvPr id="4" name="TextBox 3"/>
+          <p:cNvSpPr txBox="1"/>
+          <p:nvPr/>
+        </p:nvSpPr>
+        <p:spPr>
+          <a:xfrm>
+            <a:off x="685800" y="137160"/>
+            <a:ext cx="8229600" cy="274320"/>
+          </a:xfrm>
+          <a:prstGeom prst="rect">
+            <a:avLst/>
+          </a:prstGeom>
+          <a:noFill/>
+        </p:spPr>
+        <p:txBody>
+          <a:bodyPr wrap="square">
+            <a:spAutoFit/>
+          </a:bodyPr>
+          <a:lstStyle/>
+          <a:p>
+            <a:pPr>
+              <a:defRPr sz="1000" b="1">
+                <a:solidFill>
+                  <a:srgbClr val="A50034"/>
+                </a:solidFill>
+              </a:defRPr>
+            </a:pPr>
+            <a:r>
+              <a:t>BLOCO 4 — DEMONSTRAÇÃO &amp; RESULTADOS</a:t>
+            </a:r>
+          </a:p>
+        </p:txBody>
+      </p:sp>
+      <p:sp>
+        <p:nvSpPr>
+          <p:cNvPr id="5" name="TextBox 4"/>
+          <p:cNvSpPr txBox="1"/>
+          <p:nvPr/>
+        </p:nvSpPr>
+        <p:spPr>
+          <a:xfrm>
+            <a:off x="685800" y="365760"/>
+            <a:ext cx="8229600" cy="548640"/>
+          </a:xfrm>
+          <a:prstGeom prst="rect">
+            <a:avLst/>
+          </a:prstGeom>
+          <a:noFill/>
+        </p:spPr>
+        <p:txBody>
+          <a:bodyPr wrap="square">
+            <a:spAutoFit/>
+          </a:bodyPr>
+          <a:lstStyle/>
+          <a:p>
+            <a:pPr>
+              <a:defRPr sz="2000" b="1">
+                <a:solidFill>
+                  <a:srgbClr val="333333"/>
+                </a:solidFill>
+              </a:defRPr>
+            </a:pPr>
+            <a:r>
+              <a:t>Evidência 5: Pendência — Falta Comprovante de Residência</a:t>
+            </a:r>
+          </a:p>
+        </p:txBody>
+      </p:sp>
+      <p:sp>
+        <p:nvSpPr>
+          <p:cNvPr id="6" name="Rounded Rectangle 5"/>
+          <p:cNvSpPr/>
+          <p:nvPr/>
+        </p:nvSpPr>
+        <p:spPr>
+          <a:xfrm>
+            <a:off x="8961120" y="274320"/>
+            <a:ext cx="2743200" cy="457200"/>
+          </a:xfrm>
+          <a:prstGeom prst="roundRect">
+            <a:avLst/>
+          </a:prstGeom>
+          <a:solidFill>
+            <a:srgbClr val="A50034"/>
+          </a:solidFill>
+          <a:ln>
+            <a:noFill/>
+          </a:ln>
+        </p:spPr>
+        <p:style>
+          <a:lnRef idx="1">
+            <a:schemeClr val="accent1"/>
+          </a:lnRef>
+          <a:fillRef idx="3">
+            <a:schemeClr val="accent1"/>
+          </a:fillRef>
+          <a:effectRef idx="2">
+            <a:schemeClr val="accent1"/>
+          </a:effectRef>
+          <a:fontRef idx="minor">
+            <a:schemeClr val="lt1"/>
+          </a:fontRef>
+        </p:style>
+        <p:txBody>
+          <a:bodyPr rtlCol="0" anchor="ctr"/>
+          <a:lstStyle/>
+          <a:p>
+            <a:pPr algn="ctr">
+              <a:defRPr sz="1100" b="1">
+                <a:solidFill>
+                  <a:srgbClr val="FFFFFF"/>
+                </a:solidFill>
+              </a:defRPr>
+            </a:pPr>
+            <a:r>
+              <a:t>Equipe Integrada</a:t>
+            </a:r>
+          </a:p>
+        </p:txBody>
+      </p:sp>
+      <p:pic>
+        <p:nvPicPr>
+          <p:cNvPr id="7" name="Picture 6" descr="falha_falta-comprovante-residencia.png"/>
+          <p:cNvPicPr>
+            <a:picLocks noChangeAspect="1"/>
+          </p:cNvPicPr>
+          <p:nvPr/>
+        </p:nvPicPr>
+        <p:blipFill>
+          <a:blip r:embed="rId2"/>
+          <a:stretch>
+            <a:fillRect/>
+          </a:stretch>
+        </p:blipFill>
+        <p:spPr>
+          <a:xfrm>
+            <a:off x="548640" y="1280160"/>
+            <a:ext cx="7132320" cy="3059479"/>
+          </a:xfrm>
+          <a:prstGeom prst="rect">
+            <a:avLst/>
+          </a:prstGeom>
+        </p:spPr>
+      </p:pic>
+      <p:sp>
+        <p:nvSpPr>
+          <p:cNvPr id="8" name="Rounded Rectangle 7"/>
+          <p:cNvSpPr/>
+          <p:nvPr/>
+        </p:nvSpPr>
+        <p:spPr>
+          <a:xfrm>
+            <a:off x="7863840" y="1280160"/>
+            <a:ext cx="3749039" cy="4754880"/>
+          </a:xfrm>
+          <a:prstGeom prst="roundRect">
+            <a:avLst/>
+          </a:prstGeom>
+          <a:solidFill>
+            <a:srgbClr val="EEF1F5"/>
+          </a:solidFill>
+          <a:ln w="12700">
+            <a:solidFill>
+              <a:srgbClr val="D0D7DE"/>
+            </a:solidFill>
+          </a:ln>
+        </p:spPr>
+        <p:style>
+          <a:lnRef idx="1">
+            <a:schemeClr val="accent1"/>
+          </a:lnRef>
+          <a:fillRef idx="3">
+            <a:schemeClr val="accent1"/>
+          </a:fillRef>
+          <a:effectRef idx="2">
+            <a:schemeClr val="accent1"/>
+          </a:effectRef>
+          <a:fontRef idx="minor">
+            <a:schemeClr val="lt1"/>
+          </a:fontRef>
+        </p:style>
+        <p:txBody>
+          <a:bodyPr rtlCol="0" anchor="ctr" wrap="square" lIns="182880" rIns="182880" tIns="182880" bIns="182880"/>
+          <a:lstStyle/>
+          <a:p>
+            <a:pPr algn="ctr">
+              <a:spcAft>
+                <a:spcPts val="800"/>
+              </a:spcAft>
+              <a:defRPr sz="1400" b="1">
+                <a:solidFill>
+                  <a:srgbClr val="A50034"/>
+                </a:solidFill>
+              </a:defRPr>
+            </a:pPr>
+            <a:r>
+              <a:t>⚠️ Pendência: Residência</a:t>
+            </a:r>
+          </a:p>
+          <a:p>
+            <a:pPr>
+              <a:spcAft>
+                <a:spcPts val="600"/>
+              </a:spcAft>
+            </a:pPr>
+            <a:r>
+              <a:rPr b="1" sz="1100">
+                <a:solidFill>
+                  <a:srgbClr val="333333"/>
+                </a:solidFill>
+              </a:rPr>
+              <a:t>• Validação Documental: </a:t>
+            </a:r>
+            <a:r>
+              <a:rPr sz="1100">
+                <a:solidFill>
+                  <a:srgbClr val="333333"/>
+                </a:solidFill>
+              </a:rPr>
+              <a:t>Reprovado por Pendência.</a:t>
+            </a:r>
+          </a:p>
+          <a:p>
+            <a:pPr>
+              <a:spcAft>
+                <a:spcPts val="600"/>
+              </a:spcAft>
+            </a:pPr>
+            <a:r>
+              <a:rPr b="1" sz="1100">
+                <a:solidFill>
+                  <a:srgbClr val="333333"/>
+                </a:solidFill>
+              </a:rPr>
+              <a:t>• Inconsistência Detectada: </a:t>
+            </a:r>
+            <a:r>
+              <a:rPr sz="1100">
+                <a:solidFill>
+                  <a:srgbClr val="333333"/>
+                </a:solidFill>
+              </a:rPr>
+              <a:t>Ausência do Comprovante de Residência (fatura de água/luz/endereço) no PDF retornado.</a:t>
+            </a:r>
+          </a:p>
+          <a:p>
+            <a:pPr>
+              <a:spcAft>
+                <a:spcPts val="600"/>
+              </a:spcAft>
+            </a:pPr>
+            <a:r>
+              <a:rPr b="1" sz="1100">
+                <a:solidFill>
+                  <a:srgbClr val="333333"/>
+                </a:solidFill>
+              </a:rPr>
+              <a:t>• Gestão de Arquivos: </a:t>
+            </a:r>
+            <a:r>
+              <a:rPr sz="1100">
+                <a:solidFill>
+                  <a:srgbClr val="333333"/>
+                </a:solidFill>
+              </a:rPr>
+              <a:t>PDF movido para 'Documentos_Pendentes' no ERP e espelhado no Google Drive.</a:t>
+            </a:r>
+          </a:p>
+          <a:p>
+            <a:pPr>
+              <a:spcAft>
+                <a:spcPts val="600"/>
+              </a:spcAft>
+            </a:pPr>
+            <a:r>
+              <a:rPr b="1" sz="1100">
+                <a:solidFill>
+                  <a:srgbClr val="333333"/>
+                </a:solidFill>
+              </a:rPr>
+              <a:t>• Notificação Automática: </a:t>
+            </a:r>
+            <a:r>
+              <a:rPr sz="1100">
+                <a:solidFill>
+                  <a:srgbClr val="333333"/>
+                </a:solidFill>
+              </a:rPr>
+              <a:t>Envio de e-mail em HTML responsivo solicitando a regularização do comprovante residencial.</a:t>
+            </a:r>
+          </a:p>
+        </p:txBody>
+      </p:sp>
+      <p:sp>
+        <p:nvSpPr>
+          <p:cNvPr id="9" name="TextBox 8"/>
+          <p:cNvSpPr txBox="1"/>
+          <p:nvPr/>
+        </p:nvSpPr>
+        <p:spPr>
+          <a:xfrm>
+            <a:off x="457200" y="6400800"/>
+            <a:ext cx="11277295" cy="365760"/>
+          </a:xfrm>
+          <a:prstGeom prst="rect">
+            <a:avLst/>
+          </a:prstGeom>
+          <a:noFill/>
+        </p:spPr>
+        <p:txBody>
+          <a:bodyPr wrap="none">
+            <a:spAutoFit/>
+          </a:bodyPr>
+          <a:lstStyle/>
+          <a:p>
+            <a:pPr>
+              <a:defRPr sz="900">
+                <a:solidFill>
+                  <a:srgbClr val="666666"/>
+                </a:solidFill>
+              </a:defRPr>
+            </a:pPr>
+            <a:r>
+              <a:t>Empresa Portal Fake — Processo 1 (Setor de Atendimento) | Técnicas de Hyperautomation (LG / IFAM / FAEPI) | Slide 22 de 24</a:t>
+            </a:r>
+          </a:p>
+        </p:txBody>
+      </p:sp>
+    </p:spTree>
+  </p:cSld>
+  <p:clrMapOvr>
+    <a:masterClrMapping/>
+  </p:clrMapOvr>
+</p:sld>
+</file>
+
+<file path=ppt/slides/slide23.xml><?xml version="1.0" encoding="utf-8"?>
 <p:sld xmlns:a="http://schemas.openxmlformats.org/drawingml/2006/main" xmlns:p="http://schemas.openxmlformats.org/presentationml/2006/main" xmlns:r="http://schemas.openxmlformats.org/officeDocument/2006/relationships">
   <p:cSld>
     <p:bg>
@@ -10626,7 +11036,7 @@
 </p:sld>
 </file>
 
-<file path=ppt/slides/slide23.xml><?xml version="1.0" encoding="utf-8"?>
+<file path=ppt/slides/slide24.xml><?xml version="1.0" encoding="utf-8"?>
 <p:sld xmlns:a="http://schemas.openxmlformats.org/drawingml/2006/main" xmlns:p="http://schemas.openxmlformats.org/presentationml/2006/main" xmlns:r="http://schemas.openxmlformats.org/officeDocument/2006/relationships">
   <p:cSld>
     <p:bg>

</xml_diff>

<commit_message>
docs: adicionada imagem do diagrama BPMN 2.0 no slide 6 e relatorio tecnico
</commit_message>
<xml_diff>
--- a/docs/Apresentacao_Hyperautomation_Processo1_LG.pptx
+++ b/docs/Apresentacao_Hyperautomation_Processo1_LG.pptx
@@ -13425,16 +13425,40 @@
           </a:p>
         </p:txBody>
       </p:sp>
-      <p:sp>
-        <p:nvSpPr>
-          <p:cNvPr id="7" name="Rounded Rectangle 6"/>
+      <p:pic>
+        <p:nvPicPr>
+          <p:cNvPr id="7" name="Picture 6" descr="bpmn_atendimento_portal_fake.jpeg"/>
+          <p:cNvPicPr>
+            <a:picLocks noChangeAspect="1"/>
+          </p:cNvPicPr>
+          <p:nvPr/>
+        </p:nvPicPr>
+        <p:blipFill>
+          <a:blip r:embed="rId2"/>
+          <a:stretch>
+            <a:fillRect/>
+          </a:stretch>
+        </p:blipFill>
+        <p:spPr>
+          <a:xfrm>
+            <a:off x="548640" y="1280160"/>
+            <a:ext cx="7132320" cy="2733315"/>
+          </a:xfrm>
+          <a:prstGeom prst="rect">
+            <a:avLst/>
+          </a:prstGeom>
+        </p:spPr>
+      </p:pic>
+      <p:sp>
+        <p:nvSpPr>
+          <p:cNvPr id="8" name="Rounded Rectangle 7"/>
           <p:cNvSpPr/>
           <p:nvPr/>
         </p:nvSpPr>
         <p:spPr>
           <a:xfrm>
-            <a:off x="548640" y="1280160"/>
-            <a:ext cx="5303520" cy="4754880"/>
+            <a:off x="7863840" y="1280160"/>
+            <a:ext cx="3749039" cy="4754880"/>
           </a:xfrm>
           <a:prstGeom prst="roundRect">
             <a:avLst/>
@@ -13477,7 +13501,7 @@
               </a:defRPr>
             </a:pPr>
             <a:r>
-              <a:t>Estrutura do Diagrama BPMN 2.0 (Draw.io)</a:t>
+              <a:t>📐 Diagrama BPMN 2.0 (Draw.io)</a:t>
             </a:r>
           </a:p>
           <a:p>
@@ -13515,7 +13539,7 @@
                   <a:srgbClr val="333333"/>
                 </a:solidFill>
               </a:rPr>
-              <a:t>• Atividades Automatizadas: </a:t>
+              <a:t>• Raias (Pools/Lanes): </a:t>
             </a:r>
             <a:r>
               <a:rPr sz="1100">
@@ -13523,7 +13547,7 @@
                   <a:srgbClr val="333333"/>
                 </a:solidFill>
               </a:rPr>
-              <a:t>Geração de DOCX -&gt; Disparo SMTP -&gt; Monitoramento IMAP -&gt; Extração -&gt; Validação PDF -&gt; Cadastro Playwright -&gt; Sync Drive.</a:t>
+              <a:t>Setor de Atendimento, Robô de Hyperautomation e Portal ERP.</a:t>
             </a:r>
           </a:p>
           <a:p>
@@ -13538,7 +13562,7 @@
                   <a:srgbClr val="333333"/>
                 </a:solidFill>
               </a:rPr>
-              <a:t>• Pontos de Decisão (Gateway): </a:t>
+              <a:t>• Fluxo Automatizado: </a:t>
             </a:r>
             <a:r>
               <a:rPr sz="1100">
@@ -13546,7 +13570,7 @@
                   <a:srgbClr val="333333"/>
                 </a:solidFill>
               </a:rPr>
-              <a:t>Documentação Válida? (Sim -&gt; Documentos_OK / Não -&gt; Documentos_Pendentes).</a:t>
+              <a:t>Geração DOCX -&gt; SMTP -&gt; IMAP -&gt; pypdf -&gt; Playwright -&gt; Google Drive.</a:t>
             </a:r>
           </a:p>
           <a:p>
@@ -13561,6 +13585,29 @@
                   <a:srgbClr val="333333"/>
                 </a:solidFill>
               </a:rPr>
+              <a:t>• Gateways de Decisão: </a:t>
+            </a:r>
+            <a:r>
+              <a:rPr sz="1100">
+                <a:solidFill>
+                  <a:srgbClr val="333333"/>
+                </a:solidFill>
+              </a:rPr>
+              <a:t>Validação Documental Aprovada? (Sim -&gt; Documentos_OK / Não -&gt; Documentos_Pendentes).</a:t>
+            </a:r>
+          </a:p>
+          <a:p>
+            <a:pPr>
+              <a:spcAft>
+                <a:spcPts val="600"/>
+              </a:spcAft>
+            </a:pPr>
+            <a:r>
+              <a:rPr b="1" sz="1100">
+                <a:solidFill>
+                  <a:srgbClr val="333333"/>
+                </a:solidFill>
+              </a:rPr>
               <a:t>• Eventos Finais: </a:t>
             </a:r>
             <a:r>
@@ -13569,133 +13616,7 @@
                   <a:srgbClr val="333333"/>
                 </a:solidFill>
               </a:rPr>
-              <a:t>Confirmação enviada ao cliente &amp; PDF transferido para Encaminhados.</a:t>
-            </a:r>
-          </a:p>
-        </p:txBody>
-      </p:sp>
-      <p:sp>
-        <p:nvSpPr>
-          <p:cNvPr id="8" name="Rounded Rectangle 7"/>
-          <p:cNvSpPr/>
-          <p:nvPr/>
-        </p:nvSpPr>
-        <p:spPr>
-          <a:xfrm>
-            <a:off x="6217920" y="1280160"/>
-            <a:ext cx="5303520" cy="4754880"/>
-          </a:xfrm>
-          <a:prstGeom prst="roundRect">
-            <a:avLst/>
-          </a:prstGeom>
-          <a:solidFill>
-            <a:srgbClr val="EEF1F5"/>
-          </a:solidFill>
-          <a:ln w="12700">
-            <a:solidFill>
-              <a:srgbClr val="D0D7DE"/>
-            </a:solidFill>
-          </a:ln>
-        </p:spPr>
-        <p:style>
-          <a:lnRef idx="1">
-            <a:schemeClr val="accent1"/>
-          </a:lnRef>
-          <a:fillRef idx="3">
-            <a:schemeClr val="accent1"/>
-          </a:fillRef>
-          <a:effectRef idx="2">
-            <a:schemeClr val="accent1"/>
-          </a:effectRef>
-          <a:fontRef idx="minor">
-            <a:schemeClr val="lt1"/>
-          </a:fontRef>
-        </p:style>
-        <p:txBody>
-          <a:bodyPr rtlCol="0" anchor="ctr" wrap="square" lIns="182880" rIns="182880" tIns="182880" bIns="182880"/>
-          <a:lstStyle/>
-          <a:p>
-            <a:pPr algn="ctr">
-              <a:spcAft>
-                <a:spcPts val="800"/>
-              </a:spcAft>
-              <a:defRPr sz="1400" b="1">
-                <a:solidFill>
-                  <a:srgbClr val="A50034"/>
-                </a:solidFill>
-              </a:defRPr>
-            </a:pPr>
-            <a:r>
-              <a:t>Principais Ganhos do Modelo TO-BE</a:t>
-            </a:r>
-          </a:p>
-          <a:p>
-            <a:pPr>
-              <a:spcAft>
-                <a:spcPts val="600"/>
-              </a:spcAft>
-            </a:pPr>
-            <a:r>
-              <a:rPr b="1" sz="1100">
-                <a:solidFill>
-                  <a:srgbClr val="333333"/>
-                </a:solidFill>
-              </a:rPr>
-              <a:t>• Autonomia Total: </a:t>
-            </a:r>
-            <a:r>
-              <a:rPr sz="1100">
-                <a:solidFill>
-                  <a:srgbClr val="333333"/>
-                </a:solidFill>
-              </a:rPr>
-              <a:t>Eliminação de qualquer intervenção humana na triagem e digitação.</a:t>
-            </a:r>
-          </a:p>
-          <a:p>
-            <a:pPr>
-              <a:spcAft>
-                <a:spcPts val="600"/>
-              </a:spcAft>
-            </a:pPr>
-            <a:r>
-              <a:rPr b="1" sz="1100">
-                <a:solidFill>
-                  <a:srgbClr val="333333"/>
-                </a:solidFill>
-              </a:rPr>
-              <a:t>• Regras de Negócio Estritas: </a:t>
-            </a:r>
-            <a:r>
-              <a:rPr sz="1100">
-                <a:solidFill>
-                  <a:srgbClr val="333333"/>
-                </a:solidFill>
-              </a:rPr>
-              <a:t>Rejeição imediata de arquivos sem assinatura ou fora do padrão.</a:t>
-            </a:r>
-          </a:p>
-          <a:p>
-            <a:pPr>
-              <a:spcAft>
-                <a:spcPts val="600"/>
-              </a:spcAft>
-            </a:pPr>
-            <a:r>
-              <a:rPr b="1" sz="1100">
-                <a:solidFill>
-                  <a:srgbClr val="333333"/>
-                </a:solidFill>
-              </a:rPr>
-              <a:t>• Sincronização em Tempo Real: </a:t>
-            </a:r>
-            <a:r>
-              <a:rPr sz="1100">
-                <a:solidFill>
-                  <a:srgbClr val="333333"/>
-                </a:solidFill>
-              </a:rPr>
-              <a:t>Sincronização instantânea das movimentações com o Google Drive.</a:t>
+              <a:t>Envio de e-mail HTML com protocolo único e arquivamento em Encaminhados.</a:t>
             </a:r>
           </a:p>
         </p:txBody>

</xml_diff>